<commit_message>
Servir por HTTP (uso interno/local); HTTPS dejado indicado para produccion
- iniciar_chatbot.bat: arranca uvicorn por HTTP (sin --ssl); abre http://localhost:8000/;
  la generacion del certificado y los flags TLS quedan comentados con una nota
  [HTTPS OPCIONAL - PARA PRODUCCION] que explica como reactivar HTTPS o servir tras un
  proxy inverso. (api.py e index.html no requieren cambios: el front usa location.origin.)
- Documentacion (MD+PDF): seccion de despliegue reescrita a HTTP + apartado "Servir en
  produccion (HTTPS) - dejado indicado". Diagrama de arquitectura: flecha "HTTP / JSON".
- generar_pptx.py: nota de HTTPS -> HTTP (uso interno) en el PowerPoint de gas natural.

Co-Authored-By: Claude Opus 4.8 (1M context) <noreply@anthropic.com>
</commit_message>
<xml_diff>
--- a/docs/Presentacion_Comparador_Gas.pptx
+++ b/docs/Presentacion_Comparador_Gas.pptx
@@ -1499,7 +1499,7 @@
           <a:lstStyle/>
           <a:p>
             <a:r>
-              <a:t>El sistema ofrece cuatro funcionalidades. La consulta libre (chat) responde en lenguaje natural e incluye el análisis de interconexión en cadena: para una ruta de varios países calcula qué gas puede atravesarla entera e identifica el país y el parámetro que más restringen (el cuello de botella). La comparativa permite comparar un parámetro entre países y ver la matriz completa, con exportación a Excel o PDF. Analizar gas valida la composición de un gas concreto país a país. Todo se sirve por HTTPS y mantiene la garantía de cero cifras inventadas.</a:t>
+              <a:t>El sistema ofrece cuatro funcionalidades. La consulta libre (chat) responde en lenguaje natural e incluye el análisis de interconexión en cadena: para una ruta de varios países calcula qué gas puede atravesarla entera e identifica el país y el parámetro que más restringen (el cuello de botella). La comparativa permite comparar un parámetro entre países y ver la matriz completa, con exportación a Excel o PDF. Analizar gas valida la composición de un gas concreto país a país. Se sirve por HTTP para uso interno/local (HTTPS opcional para producción) y mantiene la garantía de cero cifras inventadas.</a:t>
             </a:r>
           </a:p>
         </p:txBody>
@@ -11163,7 +11163,7 @@
                 </a:solidFill>
                 <a:latin typeface="Calibri"/>
               </a:rPr>
-              <a:t>• Acceso por HTTPS (conexión cifrada). La IA solo interviene en el texto abierto; el resto es determinista.</a:t>
+              <a:t>• Acceso por HTTP para uso interno/local (HTTPS opcional para producción). La IA solo interviene en el texto abierto; el resto es determinista.</a:t>
             </a:r>
           </a:p>
         </p:txBody>

</xml_diff>

<commit_message>
Presentacion: el stack muestra solo la pieza clave de cada capa (2, no 5)
La diapositiva del stack era un inventario (5-6 herramientas por capa) y no
transmitia ningun mensaje. Ahora da el titular: 2 piezas por capa, cada una con
su papel en una linea. El detalle completo sigue en la tabla siguiente.

  Frontend  -> JavaScript vanilla · DOMPurify
  Backend   -> FastAPI · uvicorn
  Datos     -> PyYAML (la puerta a las cifras) · pdfplumber + SQLite
  IA        -> GPT-4o-mini · function calling

Co-Authored-By: Claude Opus 4.8 <noreply@anthropic.com>
</commit_message>
<xml_diff>
--- a/docs/Presentacion_Comparador_Gas.pptx
+++ b/docs/Presentacion_Comparador_Gas.pptx
@@ -10209,7 +10209,7 @@
                 </a:solidFill>
                 <a:latin typeface="Calibri"/>
               </a:rPr>
-              <a:t>Lo que la aplicación usa realmente, agrupado por capa.</a:t>
+              <a:t>Lo esencial de cada capa: la pieza que manda y el porqué. (El detalle completo, en la diapositiva siguiente.)</a:t>
             </a:r>
           </a:p>
         </p:txBody>
@@ -10347,14 +10347,58 @@
       </p:sp>
       <p:sp>
         <p:nvSpPr>
-          <p:cNvPr id="12" name="TextBox 11"/>
+          <p:cNvPr id="12" name="Rectangle 11"/>
+          <p:cNvSpPr/>
+          <p:nvPr/>
+        </p:nvSpPr>
+        <p:spPr>
+          <a:xfrm>
+            <a:off x="731520" y="2395728"/>
+            <a:ext cx="50292" cy="256032"/>
+          </a:xfrm>
+          <a:prstGeom prst="rect">
+            <a:avLst/>
+          </a:prstGeom>
+          <a:solidFill>
+            <a:srgbClr val="0099D6"/>
+          </a:solidFill>
+          <a:ln>
+            <a:noFill/>
+          </a:ln>
+          <a:effectLst/>
+        </p:spPr>
+        <p:style>
+          <a:lnRef idx="1">
+            <a:schemeClr val="accent1"/>
+          </a:lnRef>
+          <a:fillRef idx="3">
+            <a:schemeClr val="accent1"/>
+          </a:fillRef>
+          <a:effectRef idx="2">
+            <a:schemeClr val="accent1"/>
+          </a:effectRef>
+          <a:fontRef idx="minor">
+            <a:schemeClr val="lt1"/>
+          </a:fontRef>
+        </p:style>
+        <p:txBody>
+          <a:bodyPr rtlCol="0" anchor="ctr" wrap="square"/>
+          <a:lstStyle/>
+          <a:p>
+            <a:pPr algn="ctr"/>
+          </a:p>
+        </p:txBody>
+      </p:sp>
+      <p:sp>
+        <p:nvSpPr>
+          <p:cNvPr id="13" name="TextBox 12"/>
           <p:cNvSpPr txBox="1"/>
           <p:nvPr/>
         </p:nvSpPr>
         <p:spPr>
           <a:xfrm>
-            <a:off x="731520" y="2331720"/>
-            <a:ext cx="2377440" cy="2468880"/>
+            <a:off x="868680" y="2350008"/>
+            <a:ext cx="2240280" cy="292608"/>
           </a:xfrm>
           <a:prstGeom prst="rect">
             <a:avLst/>
@@ -10369,88 +10413,185 @@
           <a:p>
             <a:pPr algn="l">
               <a:spcAft>
-                <a:spcPts val="900"/>
-              </a:spcAft>
-            </a:pPr>
-            <a:r>
-              <a:rPr sz="1300" b="0">
-                <a:solidFill>
-                  <a:srgbClr val="1B2A38"/>
-                </a:solidFill>
-                <a:latin typeface="Calibri"/>
-              </a:rPr>
-              <a:t>• HTML + CSS</a:t>
-            </a:r>
-          </a:p>
-          <a:p>
-            <a:pPr algn="l">
-              <a:spcAft>
-                <a:spcPts val="900"/>
-              </a:spcAft>
-            </a:pPr>
-            <a:r>
-              <a:rPr sz="1300" b="0">
-                <a:solidFill>
-                  <a:srgbClr val="1B2A38"/>
-                </a:solidFill>
-                <a:latin typeface="Calibri"/>
-              </a:rPr>
-              <a:t>• JavaScript vanilla</a:t>
-            </a:r>
-          </a:p>
-          <a:p>
-            <a:pPr algn="l">
-              <a:spcAft>
-                <a:spcPts val="900"/>
-              </a:spcAft>
-            </a:pPr>
-            <a:r>
-              <a:rPr sz="1300" b="0">
-                <a:solidFill>
-                  <a:srgbClr val="1B2A38"/>
-                </a:solidFill>
-                <a:latin typeface="Calibri"/>
-              </a:rPr>
-              <a:t>• marked</a:t>
-            </a:r>
-          </a:p>
-          <a:p>
-            <a:pPr algn="l">
-              <a:spcAft>
-                <a:spcPts val="900"/>
-              </a:spcAft>
-            </a:pPr>
-            <a:r>
-              <a:rPr sz="1300" b="0">
-                <a:solidFill>
-                  <a:srgbClr val="1B2A38"/>
-                </a:solidFill>
-                <a:latin typeface="Calibri"/>
-              </a:rPr>
-              <a:t>• DOMPurify</a:t>
-            </a:r>
-          </a:p>
-          <a:p>
-            <a:pPr algn="l">
-              <a:spcAft>
-                <a:spcPts val="900"/>
-              </a:spcAft>
-            </a:pPr>
-            <a:r>
-              <a:rPr sz="1300" b="0">
-                <a:solidFill>
-                  <a:srgbClr val="1B2A38"/>
-                </a:solidFill>
-                <a:latin typeface="Calibri"/>
-              </a:rPr>
-              <a:t>• localStorage</a:t>
-            </a:r>
-          </a:p>
-        </p:txBody>
-      </p:sp>
-      <p:sp>
-        <p:nvSpPr>
-          <p:cNvPr id="13" name="Rounded Rectangle 12"/>
+                <a:spcPts val="600"/>
+              </a:spcAft>
+            </a:pPr>
+            <a:r>
+              <a:rPr sz="1400" b="1">
+                <a:solidFill>
+                  <a:srgbClr val="013A57"/>
+                </a:solidFill>
+                <a:latin typeface="Calibri"/>
+              </a:rPr>
+              <a:t>JavaScript vanilla</a:t>
+            </a:r>
+          </a:p>
+        </p:txBody>
+      </p:sp>
+      <p:sp>
+        <p:nvSpPr>
+          <p:cNvPr id="14" name="TextBox 13"/>
+          <p:cNvSpPr txBox="1"/>
+          <p:nvPr/>
+        </p:nvSpPr>
+        <p:spPr>
+          <a:xfrm>
+            <a:off x="868680" y="2670048"/>
+            <a:ext cx="2240280" cy="868680"/>
+          </a:xfrm>
+          <a:prstGeom prst="rect">
+            <a:avLst/>
+          </a:prstGeom>
+          <a:noFill/>
+        </p:spPr>
+        <p:txBody>
+          <a:bodyPr wrap="square" anchor="t" lIns="38100" rIns="38100" tIns="12700" bIns="12700">
+            <a:spAutoFit/>
+          </a:bodyPr>
+          <a:lstStyle/>
+          <a:p>
+            <a:pPr algn="l">
+              <a:spcAft>
+                <a:spcPts val="600"/>
+              </a:spcAft>
+            </a:pPr>
+            <a:r>
+              <a:rPr sz="1150" b="0">
+                <a:solidFill>
+                  <a:srgbClr val="4A5B68"/>
+                </a:solidFill>
+                <a:latin typeface="Calibri"/>
+              </a:rPr>
+              <a:t>La interfaz (index.html). Sin framework: una SPA ligera.</a:t>
+            </a:r>
+          </a:p>
+        </p:txBody>
+      </p:sp>
+      <p:sp>
+        <p:nvSpPr>
+          <p:cNvPr id="15" name="Rectangle 14"/>
+          <p:cNvSpPr/>
+          <p:nvPr/>
+        </p:nvSpPr>
+        <p:spPr>
+          <a:xfrm>
+            <a:off x="731520" y="3630168"/>
+            <a:ext cx="50292" cy="256032"/>
+          </a:xfrm>
+          <a:prstGeom prst="rect">
+            <a:avLst/>
+          </a:prstGeom>
+          <a:solidFill>
+            <a:srgbClr val="0099D6"/>
+          </a:solidFill>
+          <a:ln>
+            <a:noFill/>
+          </a:ln>
+          <a:effectLst/>
+        </p:spPr>
+        <p:style>
+          <a:lnRef idx="1">
+            <a:schemeClr val="accent1"/>
+          </a:lnRef>
+          <a:fillRef idx="3">
+            <a:schemeClr val="accent1"/>
+          </a:fillRef>
+          <a:effectRef idx="2">
+            <a:schemeClr val="accent1"/>
+          </a:effectRef>
+          <a:fontRef idx="minor">
+            <a:schemeClr val="lt1"/>
+          </a:fontRef>
+        </p:style>
+        <p:txBody>
+          <a:bodyPr rtlCol="0" anchor="ctr" wrap="square"/>
+          <a:lstStyle/>
+          <a:p>
+            <a:pPr algn="ctr"/>
+          </a:p>
+        </p:txBody>
+      </p:sp>
+      <p:sp>
+        <p:nvSpPr>
+          <p:cNvPr id="16" name="TextBox 15"/>
+          <p:cNvSpPr txBox="1"/>
+          <p:nvPr/>
+        </p:nvSpPr>
+        <p:spPr>
+          <a:xfrm>
+            <a:off x="868680" y="3584448"/>
+            <a:ext cx="2240280" cy="292608"/>
+          </a:xfrm>
+          <a:prstGeom prst="rect">
+            <a:avLst/>
+          </a:prstGeom>
+          <a:noFill/>
+        </p:spPr>
+        <p:txBody>
+          <a:bodyPr wrap="square" anchor="t" lIns="38100" rIns="38100" tIns="12700" bIns="12700">
+            <a:spAutoFit/>
+          </a:bodyPr>
+          <a:lstStyle/>
+          <a:p>
+            <a:pPr algn="l">
+              <a:spcAft>
+                <a:spcPts val="600"/>
+              </a:spcAft>
+            </a:pPr>
+            <a:r>
+              <a:rPr sz="1400" b="1">
+                <a:solidFill>
+                  <a:srgbClr val="013A57"/>
+                </a:solidFill>
+                <a:latin typeface="Calibri"/>
+              </a:rPr>
+              <a:t>DOMPurify</a:t>
+            </a:r>
+          </a:p>
+        </p:txBody>
+      </p:sp>
+      <p:sp>
+        <p:nvSpPr>
+          <p:cNvPr id="17" name="TextBox 16"/>
+          <p:cNvSpPr txBox="1"/>
+          <p:nvPr/>
+        </p:nvSpPr>
+        <p:spPr>
+          <a:xfrm>
+            <a:off x="868680" y="3904488"/>
+            <a:ext cx="2240280" cy="868680"/>
+          </a:xfrm>
+          <a:prstGeom prst="rect">
+            <a:avLst/>
+          </a:prstGeom>
+          <a:noFill/>
+        </p:spPr>
+        <p:txBody>
+          <a:bodyPr wrap="square" anchor="t" lIns="38100" rIns="38100" tIns="12700" bIns="12700">
+            <a:spAutoFit/>
+          </a:bodyPr>
+          <a:lstStyle/>
+          <a:p>
+            <a:pPr algn="l">
+              <a:spcAft>
+                <a:spcPts val="600"/>
+              </a:spcAft>
+            </a:pPr>
+            <a:r>
+              <a:rPr sz="1150" b="0">
+                <a:solidFill>
+                  <a:srgbClr val="4A5B68"/>
+                </a:solidFill>
+                <a:latin typeface="Calibri"/>
+              </a:rPr>
+              <a:t>Sanea el HTML de la respuesta antes de pintarlo (anti-XSS).</a:t>
+            </a:r>
+          </a:p>
+        </p:txBody>
+      </p:sp>
+      <p:sp>
+        <p:nvSpPr>
+          <p:cNvPr id="18" name="Rounded Rectangle 17"/>
           <p:cNvSpPr/>
           <p:nvPr/>
         </p:nvSpPr>
@@ -10498,7 +10639,7 @@
       </p:sp>
       <p:sp>
         <p:nvSpPr>
-          <p:cNvPr id="14" name="Rectangle 13"/>
+          <p:cNvPr id="19" name="Rectangle 18"/>
           <p:cNvSpPr/>
           <p:nvPr/>
         </p:nvSpPr>
@@ -10542,7 +10683,7 @@
       </p:sp>
       <p:sp>
         <p:nvSpPr>
-          <p:cNvPr id="15" name="TextBox 14"/>
+          <p:cNvPr id="20" name="TextBox 19"/>
           <p:cNvSpPr txBox="1"/>
           <p:nvPr/>
         </p:nvSpPr>
@@ -10581,14 +10722,58 @@
       </p:sp>
       <p:sp>
         <p:nvSpPr>
-          <p:cNvPr id="16" name="TextBox 15"/>
+          <p:cNvPr id="21" name="Rectangle 20"/>
+          <p:cNvSpPr/>
+          <p:nvPr/>
+        </p:nvSpPr>
+        <p:spPr>
+          <a:xfrm>
+            <a:off x="3575304" y="2395728"/>
+            <a:ext cx="50292" cy="256032"/>
+          </a:xfrm>
+          <a:prstGeom prst="rect">
+            <a:avLst/>
+          </a:prstGeom>
+          <a:solidFill>
+            <a:srgbClr val="013A57"/>
+          </a:solidFill>
+          <a:ln>
+            <a:noFill/>
+          </a:ln>
+          <a:effectLst/>
+        </p:spPr>
+        <p:style>
+          <a:lnRef idx="1">
+            <a:schemeClr val="accent1"/>
+          </a:lnRef>
+          <a:fillRef idx="3">
+            <a:schemeClr val="accent1"/>
+          </a:fillRef>
+          <a:effectRef idx="2">
+            <a:schemeClr val="accent1"/>
+          </a:effectRef>
+          <a:fontRef idx="minor">
+            <a:schemeClr val="lt1"/>
+          </a:fontRef>
+        </p:style>
+        <p:txBody>
+          <a:bodyPr rtlCol="0" anchor="ctr" wrap="square"/>
+          <a:lstStyle/>
+          <a:p>
+            <a:pPr algn="ctr"/>
+          </a:p>
+        </p:txBody>
+      </p:sp>
+      <p:sp>
+        <p:nvSpPr>
+          <p:cNvPr id="22" name="TextBox 21"/>
           <p:cNvSpPr txBox="1"/>
           <p:nvPr/>
         </p:nvSpPr>
         <p:spPr>
           <a:xfrm>
-            <a:off x="3575304" y="2331720"/>
-            <a:ext cx="2377440" cy="2468880"/>
+            <a:off x="3712463" y="2350008"/>
+            <a:ext cx="2240280" cy="292608"/>
           </a:xfrm>
           <a:prstGeom prst="rect">
             <a:avLst/>
@@ -10603,88 +10788,185 @@
           <a:p>
             <a:pPr algn="l">
               <a:spcAft>
-                <a:spcPts val="900"/>
-              </a:spcAft>
-            </a:pPr>
-            <a:r>
-              <a:rPr sz="1300" b="0">
-                <a:solidFill>
-                  <a:srgbClr val="1B2A38"/>
-                </a:solidFill>
-                <a:latin typeface="Calibri"/>
-              </a:rPr>
-              <a:t>• Python 3.11+</a:t>
-            </a:r>
-          </a:p>
-          <a:p>
-            <a:pPr algn="l">
-              <a:spcAft>
-                <a:spcPts val="900"/>
-              </a:spcAft>
-            </a:pPr>
-            <a:r>
-              <a:rPr sz="1300" b="0">
-                <a:solidFill>
-                  <a:srgbClr val="1B2A38"/>
-                </a:solidFill>
-                <a:latin typeface="Calibri"/>
-              </a:rPr>
-              <a:t>• FastAPI</a:t>
-            </a:r>
-          </a:p>
-          <a:p>
-            <a:pPr algn="l">
-              <a:spcAft>
-                <a:spcPts val="900"/>
-              </a:spcAft>
-            </a:pPr>
-            <a:r>
-              <a:rPr sz="1300" b="0">
-                <a:solidFill>
-                  <a:srgbClr val="1B2A38"/>
-                </a:solidFill>
-                <a:latin typeface="Calibri"/>
-              </a:rPr>
-              <a:t>• uvicorn</a:t>
-            </a:r>
-          </a:p>
-          <a:p>
-            <a:pPr algn="l">
-              <a:spcAft>
-                <a:spcPts val="900"/>
-              </a:spcAft>
-            </a:pPr>
-            <a:r>
-              <a:rPr sz="1300" b="0">
-                <a:solidFill>
-                  <a:srgbClr val="1B2A38"/>
-                </a:solidFill>
-                <a:latin typeface="Calibri"/>
-              </a:rPr>
-              <a:t>• pydantic</a:t>
-            </a:r>
-          </a:p>
-          <a:p>
-            <a:pPr algn="l">
-              <a:spcAft>
-                <a:spcPts val="900"/>
-              </a:spcAft>
-            </a:pPr>
-            <a:r>
-              <a:rPr sz="1300" b="0">
-                <a:solidFill>
-                  <a:srgbClr val="1B2A38"/>
-                </a:solidFill>
-                <a:latin typeface="Calibri"/>
-              </a:rPr>
-              <a:t>• python-dotenv</a:t>
-            </a:r>
-          </a:p>
-        </p:txBody>
-      </p:sp>
-      <p:sp>
-        <p:nvSpPr>
-          <p:cNvPr id="17" name="Rounded Rectangle 16"/>
+                <a:spcPts val="600"/>
+              </a:spcAft>
+            </a:pPr>
+            <a:r>
+              <a:rPr sz="1400" b="1">
+                <a:solidFill>
+                  <a:srgbClr val="013A57"/>
+                </a:solidFill>
+                <a:latin typeface="Calibri"/>
+              </a:rPr>
+              <a:t>FastAPI</a:t>
+            </a:r>
+          </a:p>
+        </p:txBody>
+      </p:sp>
+      <p:sp>
+        <p:nvSpPr>
+          <p:cNvPr id="23" name="TextBox 22"/>
+          <p:cNvSpPr txBox="1"/>
+          <p:nvPr/>
+        </p:nvSpPr>
+        <p:spPr>
+          <a:xfrm>
+            <a:off x="3712463" y="2670048"/>
+            <a:ext cx="2240280" cy="868680"/>
+          </a:xfrm>
+          <a:prstGeom prst="rect">
+            <a:avLst/>
+          </a:prstGeom>
+          <a:noFill/>
+        </p:spPr>
+        <p:txBody>
+          <a:bodyPr wrap="square" anchor="t" lIns="38100" rIns="38100" tIns="12700" bIns="12700">
+            <a:spAutoFit/>
+          </a:bodyPr>
+          <a:lstStyle/>
+          <a:p>
+            <a:pPr algn="l">
+              <a:spcAft>
+                <a:spcPts val="600"/>
+              </a:spcAft>
+            </a:pPr>
+            <a:r>
+              <a:rPr sz="1150" b="0">
+                <a:solidFill>
+                  <a:srgbClr val="4A5B68"/>
+                </a:solidFill>
+                <a:latin typeface="Calibri"/>
+              </a:rPr>
+              <a:t>NUESTRO servidor: define y expone los endpoints. Propio y gratuito.</a:t>
+            </a:r>
+          </a:p>
+        </p:txBody>
+      </p:sp>
+      <p:sp>
+        <p:nvSpPr>
+          <p:cNvPr id="24" name="Rectangle 23"/>
+          <p:cNvSpPr/>
+          <p:nvPr/>
+        </p:nvSpPr>
+        <p:spPr>
+          <a:xfrm>
+            <a:off x="3575304" y="3630168"/>
+            <a:ext cx="50292" cy="256032"/>
+          </a:xfrm>
+          <a:prstGeom prst="rect">
+            <a:avLst/>
+          </a:prstGeom>
+          <a:solidFill>
+            <a:srgbClr val="013A57"/>
+          </a:solidFill>
+          <a:ln>
+            <a:noFill/>
+          </a:ln>
+          <a:effectLst/>
+        </p:spPr>
+        <p:style>
+          <a:lnRef idx="1">
+            <a:schemeClr val="accent1"/>
+          </a:lnRef>
+          <a:fillRef idx="3">
+            <a:schemeClr val="accent1"/>
+          </a:fillRef>
+          <a:effectRef idx="2">
+            <a:schemeClr val="accent1"/>
+          </a:effectRef>
+          <a:fontRef idx="minor">
+            <a:schemeClr val="lt1"/>
+          </a:fontRef>
+        </p:style>
+        <p:txBody>
+          <a:bodyPr rtlCol="0" anchor="ctr" wrap="square"/>
+          <a:lstStyle/>
+          <a:p>
+            <a:pPr algn="ctr"/>
+          </a:p>
+        </p:txBody>
+      </p:sp>
+      <p:sp>
+        <p:nvSpPr>
+          <p:cNvPr id="25" name="TextBox 24"/>
+          <p:cNvSpPr txBox="1"/>
+          <p:nvPr/>
+        </p:nvSpPr>
+        <p:spPr>
+          <a:xfrm>
+            <a:off x="3712463" y="3584448"/>
+            <a:ext cx="2240280" cy="292608"/>
+          </a:xfrm>
+          <a:prstGeom prst="rect">
+            <a:avLst/>
+          </a:prstGeom>
+          <a:noFill/>
+        </p:spPr>
+        <p:txBody>
+          <a:bodyPr wrap="square" anchor="t" lIns="38100" rIns="38100" tIns="12700" bIns="12700">
+            <a:spAutoFit/>
+          </a:bodyPr>
+          <a:lstStyle/>
+          <a:p>
+            <a:pPr algn="l">
+              <a:spcAft>
+                <a:spcPts val="600"/>
+              </a:spcAft>
+            </a:pPr>
+            <a:r>
+              <a:rPr sz="1400" b="1">
+                <a:solidFill>
+                  <a:srgbClr val="013A57"/>
+                </a:solidFill>
+                <a:latin typeface="Calibri"/>
+              </a:rPr>
+              <a:t>uvicorn</a:t>
+            </a:r>
+          </a:p>
+        </p:txBody>
+      </p:sp>
+      <p:sp>
+        <p:nvSpPr>
+          <p:cNvPr id="26" name="TextBox 25"/>
+          <p:cNvSpPr txBox="1"/>
+          <p:nvPr/>
+        </p:nvSpPr>
+        <p:spPr>
+          <a:xfrm>
+            <a:off x="3712463" y="3904488"/>
+            <a:ext cx="2240280" cy="868680"/>
+          </a:xfrm>
+          <a:prstGeom prst="rect">
+            <a:avLst/>
+          </a:prstGeom>
+          <a:noFill/>
+        </p:spPr>
+        <p:txBody>
+          <a:bodyPr wrap="square" anchor="t" lIns="38100" rIns="38100" tIns="12700" bIns="12700">
+            <a:spAutoFit/>
+          </a:bodyPr>
+          <a:lstStyle/>
+          <a:p>
+            <a:pPr algn="l">
+              <a:spcAft>
+                <a:spcPts val="600"/>
+              </a:spcAft>
+            </a:pPr>
+            <a:r>
+              <a:rPr sz="1150" b="0">
+                <a:solidFill>
+                  <a:srgbClr val="4A5B68"/>
+                </a:solidFill>
+                <a:latin typeface="Calibri"/>
+              </a:rPr>
+              <a:t>Lo ejecuta y atiende las peticiones en el puerto 8000.</a:t>
+            </a:r>
+          </a:p>
+        </p:txBody>
+      </p:sp>
+      <p:sp>
+        <p:nvSpPr>
+          <p:cNvPr id="27" name="Rounded Rectangle 26"/>
           <p:cNvSpPr/>
           <p:nvPr/>
         </p:nvSpPr>
@@ -10732,7 +11014,7 @@
       </p:sp>
       <p:sp>
         <p:nvSpPr>
-          <p:cNvPr id="18" name="Rectangle 17"/>
+          <p:cNvPr id="28" name="Rectangle 27"/>
           <p:cNvSpPr/>
           <p:nvPr/>
         </p:nvSpPr>
@@ -10776,7 +11058,7 @@
       </p:sp>
       <p:sp>
         <p:nvSpPr>
-          <p:cNvPr id="19" name="TextBox 18"/>
+          <p:cNvPr id="29" name="TextBox 28"/>
           <p:cNvSpPr txBox="1"/>
           <p:nvPr/>
         </p:nvSpPr>
@@ -10815,14 +11097,58 @@
       </p:sp>
       <p:sp>
         <p:nvSpPr>
-          <p:cNvPr id="20" name="TextBox 19"/>
+          <p:cNvPr id="30" name="Rectangle 29"/>
+          <p:cNvSpPr/>
+          <p:nvPr/>
+        </p:nvSpPr>
+        <p:spPr>
+          <a:xfrm>
+            <a:off x="6419088" y="2395728"/>
+            <a:ext cx="50292" cy="256032"/>
+          </a:xfrm>
+          <a:prstGeom prst="rect">
+            <a:avLst/>
+          </a:prstGeom>
+          <a:solidFill>
+            <a:srgbClr val="6CB33E"/>
+          </a:solidFill>
+          <a:ln>
+            <a:noFill/>
+          </a:ln>
+          <a:effectLst/>
+        </p:spPr>
+        <p:style>
+          <a:lnRef idx="1">
+            <a:schemeClr val="accent1"/>
+          </a:lnRef>
+          <a:fillRef idx="3">
+            <a:schemeClr val="accent1"/>
+          </a:fillRef>
+          <a:effectRef idx="2">
+            <a:schemeClr val="accent1"/>
+          </a:effectRef>
+          <a:fontRef idx="minor">
+            <a:schemeClr val="lt1"/>
+          </a:fontRef>
+        </p:style>
+        <p:txBody>
+          <a:bodyPr rtlCol="0" anchor="ctr" wrap="square"/>
+          <a:lstStyle/>
+          <a:p>
+            <a:pPr algn="ctr"/>
+          </a:p>
+        </p:txBody>
+      </p:sp>
+      <p:sp>
+        <p:nvSpPr>
+          <p:cNvPr id="31" name="TextBox 30"/>
           <p:cNvSpPr txBox="1"/>
           <p:nvPr/>
         </p:nvSpPr>
         <p:spPr>
           <a:xfrm>
-            <a:off x="6419088" y="2331720"/>
-            <a:ext cx="2377440" cy="2468880"/>
+            <a:off x="6556248" y="2350008"/>
+            <a:ext cx="2240280" cy="292608"/>
           </a:xfrm>
           <a:prstGeom prst="rect">
             <a:avLst/>
@@ -10837,88 +11163,185 @@
           <a:p>
             <a:pPr algn="l">
               <a:spcAft>
-                <a:spcPts val="900"/>
-              </a:spcAft>
-            </a:pPr>
-            <a:r>
-              <a:rPr sz="1300" b="0">
-                <a:solidFill>
-                  <a:srgbClr val="1B2A38"/>
-                </a:solidFill>
-                <a:latin typeface="Calibri"/>
-              </a:rPr>
-              <a:t>• PyYAML</a:t>
-            </a:r>
-          </a:p>
-          <a:p>
-            <a:pPr algn="l">
-              <a:spcAft>
-                <a:spcPts val="900"/>
-              </a:spcAft>
-            </a:pPr>
-            <a:r>
-              <a:rPr sz="1300" b="0">
-                <a:solidFill>
-                  <a:srgbClr val="1B2A38"/>
-                </a:solidFill>
-                <a:latin typeface="Calibri"/>
-              </a:rPr>
-              <a:t>• SQLite</a:t>
-            </a:r>
-          </a:p>
-          <a:p>
-            <a:pPr algn="l">
-              <a:spcAft>
-                <a:spcPts val="900"/>
-              </a:spcAft>
-            </a:pPr>
-            <a:r>
-              <a:rPr sz="1300" b="0">
-                <a:solidFill>
-                  <a:srgbClr val="1B2A38"/>
-                </a:solidFill>
-                <a:latin typeface="Calibri"/>
-              </a:rPr>
-              <a:t>• pdfplumber</a:t>
-            </a:r>
-          </a:p>
-          <a:p>
-            <a:pPr algn="l">
-              <a:spcAft>
-                <a:spcPts val="900"/>
-              </a:spcAft>
-            </a:pPr>
-            <a:r>
-              <a:rPr sz="1300" b="0">
-                <a:solidFill>
-                  <a:srgbClr val="1B2A38"/>
-                </a:solidFill>
-                <a:latin typeface="Calibri"/>
-              </a:rPr>
-              <a:t>• openpyxl</a:t>
-            </a:r>
-          </a:p>
-          <a:p>
-            <a:pPr algn="l">
-              <a:spcAft>
-                <a:spcPts val="900"/>
-              </a:spcAft>
-            </a:pPr>
-            <a:r>
-              <a:rPr sz="1300" b="0">
-                <a:solidFill>
-                  <a:srgbClr val="1B2A38"/>
-                </a:solidFill>
-                <a:latin typeface="Calibri"/>
-              </a:rPr>
-              <a:t>• xhtml2pdf</a:t>
-            </a:r>
-          </a:p>
-        </p:txBody>
-      </p:sp>
-      <p:sp>
-        <p:nvSpPr>
-          <p:cNvPr id="21" name="Rounded Rectangle 20"/>
+                <a:spcPts val="600"/>
+              </a:spcAft>
+            </a:pPr>
+            <a:r>
+              <a:rPr sz="1400" b="1">
+                <a:solidFill>
+                  <a:srgbClr val="013A57"/>
+                </a:solidFill>
+                <a:latin typeface="Calibri"/>
+              </a:rPr>
+              <a:t>PyYAML</a:t>
+            </a:r>
+          </a:p>
+        </p:txBody>
+      </p:sp>
+      <p:sp>
+        <p:nvSpPr>
+          <p:cNvPr id="32" name="TextBox 31"/>
+          <p:cNvSpPr txBox="1"/>
+          <p:nvPr/>
+        </p:nvSpPr>
+        <p:spPr>
+          <a:xfrm>
+            <a:off x="6556248" y="2670048"/>
+            <a:ext cx="2240280" cy="868680"/>
+          </a:xfrm>
+          <a:prstGeom prst="rect">
+            <a:avLst/>
+          </a:prstGeom>
+          <a:noFill/>
+        </p:spPr>
+        <p:txBody>
+          <a:bodyPr wrap="square" anchor="t" lIns="38100" rIns="38100" tIns="12700" bIns="12700">
+            <a:spAutoFit/>
+          </a:bodyPr>
+          <a:lstStyle/>
+          <a:p>
+            <a:pPr algn="l">
+              <a:spcAft>
+                <a:spcPts val="600"/>
+              </a:spcAft>
+            </a:pPr>
+            <a:r>
+              <a:rPr sz="1150" b="0">
+                <a:solidFill>
+                  <a:srgbClr val="4A5B68"/>
+                </a:solidFill>
+                <a:latin typeface="Calibri"/>
+              </a:rPr>
+              <a:t>Lee la ONTOLOGÍA: la puerta a TODAS las cifras del sistema.</a:t>
+            </a:r>
+          </a:p>
+        </p:txBody>
+      </p:sp>
+      <p:sp>
+        <p:nvSpPr>
+          <p:cNvPr id="33" name="Rectangle 32"/>
+          <p:cNvSpPr/>
+          <p:nvPr/>
+        </p:nvSpPr>
+        <p:spPr>
+          <a:xfrm>
+            <a:off x="6419088" y="3630168"/>
+            <a:ext cx="50292" cy="256032"/>
+          </a:xfrm>
+          <a:prstGeom prst="rect">
+            <a:avLst/>
+          </a:prstGeom>
+          <a:solidFill>
+            <a:srgbClr val="6CB33E"/>
+          </a:solidFill>
+          <a:ln>
+            <a:noFill/>
+          </a:ln>
+          <a:effectLst/>
+        </p:spPr>
+        <p:style>
+          <a:lnRef idx="1">
+            <a:schemeClr val="accent1"/>
+          </a:lnRef>
+          <a:fillRef idx="3">
+            <a:schemeClr val="accent1"/>
+          </a:fillRef>
+          <a:effectRef idx="2">
+            <a:schemeClr val="accent1"/>
+          </a:effectRef>
+          <a:fontRef idx="minor">
+            <a:schemeClr val="lt1"/>
+          </a:fontRef>
+        </p:style>
+        <p:txBody>
+          <a:bodyPr rtlCol="0" anchor="ctr" wrap="square"/>
+          <a:lstStyle/>
+          <a:p>
+            <a:pPr algn="ctr"/>
+          </a:p>
+        </p:txBody>
+      </p:sp>
+      <p:sp>
+        <p:nvSpPr>
+          <p:cNvPr id="34" name="TextBox 33"/>
+          <p:cNvSpPr txBox="1"/>
+          <p:nvPr/>
+        </p:nvSpPr>
+        <p:spPr>
+          <a:xfrm>
+            <a:off x="6556248" y="3584448"/>
+            <a:ext cx="2240280" cy="292608"/>
+          </a:xfrm>
+          <a:prstGeom prst="rect">
+            <a:avLst/>
+          </a:prstGeom>
+          <a:noFill/>
+        </p:spPr>
+        <p:txBody>
+          <a:bodyPr wrap="square" anchor="t" lIns="38100" rIns="38100" tIns="12700" bIns="12700">
+            <a:spAutoFit/>
+          </a:bodyPr>
+          <a:lstStyle/>
+          <a:p>
+            <a:pPr algn="l">
+              <a:spcAft>
+                <a:spcPts val="600"/>
+              </a:spcAft>
+            </a:pPr>
+            <a:r>
+              <a:rPr sz="1400" b="1">
+                <a:solidFill>
+                  <a:srgbClr val="013A57"/>
+                </a:solidFill>
+                <a:latin typeface="Calibri"/>
+              </a:rPr>
+              <a:t>pdfplumber + SQLite</a:t>
+            </a:r>
+          </a:p>
+        </p:txBody>
+      </p:sp>
+      <p:sp>
+        <p:nvSpPr>
+          <p:cNvPr id="35" name="TextBox 34"/>
+          <p:cNvSpPr txBox="1"/>
+          <p:nvPr/>
+        </p:nvSpPr>
+        <p:spPr>
+          <a:xfrm>
+            <a:off x="6556248" y="3904488"/>
+            <a:ext cx="2240280" cy="868680"/>
+          </a:xfrm>
+          <a:prstGeom prst="rect">
+            <a:avLst/>
+          </a:prstGeom>
+          <a:noFill/>
+        </p:spPr>
+        <p:txBody>
+          <a:bodyPr wrap="square" anchor="t" lIns="38100" rIns="38100" tIns="12700" bIns="12700">
+            <a:spAutoFit/>
+          </a:bodyPr>
+          <a:lstStyle/>
+          <a:p>
+            <a:pPr algn="l">
+              <a:spcAft>
+                <a:spcPts val="600"/>
+              </a:spcAft>
+            </a:pPr>
+            <a:r>
+              <a:rPr sz="1150" b="0">
+                <a:solidFill>
+                  <a:srgbClr val="4A5B68"/>
+                </a:solidFill>
+                <a:latin typeface="Calibri"/>
+              </a:rPr>
+              <a:t>Extraen e indexan el texto de los PDF (RAG). Ninguna cifra.</a:t>
+            </a:r>
+          </a:p>
+        </p:txBody>
+      </p:sp>
+      <p:sp>
+        <p:nvSpPr>
+          <p:cNvPr id="36" name="Rounded Rectangle 35"/>
           <p:cNvSpPr/>
           <p:nvPr/>
         </p:nvSpPr>
@@ -10966,7 +11389,7 @@
       </p:sp>
       <p:sp>
         <p:nvSpPr>
-          <p:cNvPr id="22" name="Rectangle 21"/>
+          <p:cNvPr id="37" name="Rectangle 36"/>
           <p:cNvSpPr/>
           <p:nvPr/>
         </p:nvSpPr>
@@ -11010,7 +11433,7 @@
       </p:sp>
       <p:sp>
         <p:nvSpPr>
-          <p:cNvPr id="23" name="TextBox 22"/>
+          <p:cNvPr id="38" name="TextBox 37"/>
           <p:cNvSpPr txBox="1"/>
           <p:nvPr/>
         </p:nvSpPr>
@@ -11049,14 +11472,58 @@
       </p:sp>
       <p:sp>
         <p:nvSpPr>
-          <p:cNvPr id="24" name="TextBox 23"/>
+          <p:cNvPr id="39" name="Rectangle 38"/>
+          <p:cNvSpPr/>
+          <p:nvPr/>
+        </p:nvSpPr>
+        <p:spPr>
+          <a:xfrm>
+            <a:off x="9262872" y="2395728"/>
+            <a:ext cx="50292" cy="256032"/>
+          </a:xfrm>
+          <a:prstGeom prst="rect">
+            <a:avLst/>
+          </a:prstGeom>
+          <a:solidFill>
+            <a:srgbClr val="E88A1A"/>
+          </a:solidFill>
+          <a:ln>
+            <a:noFill/>
+          </a:ln>
+          <a:effectLst/>
+        </p:spPr>
+        <p:style>
+          <a:lnRef idx="1">
+            <a:schemeClr val="accent1"/>
+          </a:lnRef>
+          <a:fillRef idx="3">
+            <a:schemeClr val="accent1"/>
+          </a:fillRef>
+          <a:effectRef idx="2">
+            <a:schemeClr val="accent1"/>
+          </a:effectRef>
+          <a:fontRef idx="minor">
+            <a:schemeClr val="lt1"/>
+          </a:fontRef>
+        </p:style>
+        <p:txBody>
+          <a:bodyPr rtlCol="0" anchor="ctr" wrap="square"/>
+          <a:lstStyle/>
+          <a:p>
+            <a:pPr algn="ctr"/>
+          </a:p>
+        </p:txBody>
+      </p:sp>
+      <p:sp>
+        <p:nvSpPr>
+          <p:cNvPr id="40" name="TextBox 39"/>
           <p:cNvSpPr txBox="1"/>
           <p:nvPr/>
         </p:nvSpPr>
         <p:spPr>
           <a:xfrm>
-            <a:off x="9262872" y="2331720"/>
-            <a:ext cx="2377440" cy="2468880"/>
+            <a:off x="9400032" y="2350008"/>
+            <a:ext cx="2240280" cy="292608"/>
           </a:xfrm>
           <a:prstGeom prst="rect">
             <a:avLst/>
@@ -11071,88 +11538,185 @@
           <a:p>
             <a:pPr algn="l">
               <a:spcAft>
-                <a:spcPts val="900"/>
-              </a:spcAft>
-            </a:pPr>
-            <a:r>
-              <a:rPr sz="1300" b="0">
-                <a:solidFill>
-                  <a:srgbClr val="1B2A38"/>
-                </a:solidFill>
-                <a:latin typeface="Calibri"/>
-              </a:rPr>
-              <a:t>• OpenAI SDK</a:t>
-            </a:r>
-          </a:p>
-          <a:p>
-            <a:pPr algn="l">
-              <a:spcAft>
-                <a:spcPts val="900"/>
-              </a:spcAft>
-            </a:pPr>
-            <a:r>
-              <a:rPr sz="1300" b="0">
-                <a:solidFill>
-                  <a:srgbClr val="1B2A38"/>
-                </a:solidFill>
-                <a:latin typeface="Calibri"/>
-              </a:rPr>
-              <a:t>• GPT-4o-mini</a:t>
-            </a:r>
-          </a:p>
-          <a:p>
-            <a:pPr algn="l">
-              <a:spcAft>
-                <a:spcPts val="900"/>
-              </a:spcAft>
-            </a:pPr>
-            <a:r>
-              <a:rPr sz="1300" b="0">
-                <a:solidFill>
-                  <a:srgbClr val="1B2A38"/>
-                </a:solidFill>
-                <a:latin typeface="Calibri"/>
-              </a:rPr>
-              <a:t>• function calling</a:t>
-            </a:r>
-          </a:p>
-          <a:p>
-            <a:pPr algn="l">
-              <a:spcAft>
-                <a:spcPts val="900"/>
-              </a:spcAft>
-            </a:pPr>
-            <a:r>
-              <a:rPr sz="1300" b="0">
-                <a:solidFill>
-                  <a:srgbClr val="1B2A38"/>
-                </a:solidFill>
-                <a:latin typeface="Calibri"/>
-              </a:rPr>
-              <a:t>• temperatura 0</a:t>
-            </a:r>
-          </a:p>
-          <a:p>
-            <a:pPr algn="l">
-              <a:spcAft>
-                <a:spcPts val="900"/>
-              </a:spcAft>
-            </a:pPr>
-            <a:r>
-              <a:rPr sz="1300" b="0">
-                <a:solidFill>
-                  <a:srgbClr val="1B2A38"/>
-                </a:solidFill>
-                <a:latin typeface="Calibri"/>
-              </a:rPr>
-              <a:t>• sustituible</a:t>
-            </a:r>
-          </a:p>
-        </p:txBody>
-      </p:sp>
-      <p:sp>
-        <p:nvSpPr>
-          <p:cNvPr id="25" name="Rectangle 24"/>
+                <a:spcPts val="600"/>
+              </a:spcAft>
+            </a:pPr>
+            <a:r>
+              <a:rPr sz="1400" b="1">
+                <a:solidFill>
+                  <a:srgbClr val="013A57"/>
+                </a:solidFill>
+                <a:latin typeface="Calibri"/>
+              </a:rPr>
+              <a:t>GPT-4o-mini</a:t>
+            </a:r>
+          </a:p>
+        </p:txBody>
+      </p:sp>
+      <p:sp>
+        <p:nvSpPr>
+          <p:cNvPr id="41" name="TextBox 40"/>
+          <p:cNvSpPr txBox="1"/>
+          <p:nvPr/>
+        </p:nvSpPr>
+        <p:spPr>
+          <a:xfrm>
+            <a:off x="9400032" y="2670048"/>
+            <a:ext cx="2240280" cy="868680"/>
+          </a:xfrm>
+          <a:prstGeom prst="rect">
+            <a:avLst/>
+          </a:prstGeom>
+          <a:noFill/>
+        </p:spPr>
+        <p:txBody>
+          <a:bodyPr wrap="square" anchor="t" lIns="38100" rIns="38100" tIns="12700" bIns="12700">
+            <a:spAutoFit/>
+          </a:bodyPr>
+          <a:lstStyle/>
+          <a:p>
+            <a:pPr algn="l">
+              <a:spcAft>
+                <a:spcPts val="600"/>
+              </a:spcAft>
+            </a:pPr>
+            <a:r>
+              <a:rPr sz="1150" b="0">
+                <a:solidFill>
+                  <a:srgbClr val="4A5B68"/>
+                </a:solidFill>
+                <a:latin typeface="Calibri"/>
+              </a:rPr>
+              <a:t>Interpreta y REDACTA, a temperatura 0. Nunca genera cifras.</a:t>
+            </a:r>
+          </a:p>
+        </p:txBody>
+      </p:sp>
+      <p:sp>
+        <p:nvSpPr>
+          <p:cNvPr id="42" name="Rectangle 41"/>
+          <p:cNvSpPr/>
+          <p:nvPr/>
+        </p:nvSpPr>
+        <p:spPr>
+          <a:xfrm>
+            <a:off x="9262872" y="3630168"/>
+            <a:ext cx="50292" cy="256032"/>
+          </a:xfrm>
+          <a:prstGeom prst="rect">
+            <a:avLst/>
+          </a:prstGeom>
+          <a:solidFill>
+            <a:srgbClr val="E88A1A"/>
+          </a:solidFill>
+          <a:ln>
+            <a:noFill/>
+          </a:ln>
+          <a:effectLst/>
+        </p:spPr>
+        <p:style>
+          <a:lnRef idx="1">
+            <a:schemeClr val="accent1"/>
+          </a:lnRef>
+          <a:fillRef idx="3">
+            <a:schemeClr val="accent1"/>
+          </a:fillRef>
+          <a:effectRef idx="2">
+            <a:schemeClr val="accent1"/>
+          </a:effectRef>
+          <a:fontRef idx="minor">
+            <a:schemeClr val="lt1"/>
+          </a:fontRef>
+        </p:style>
+        <p:txBody>
+          <a:bodyPr rtlCol="0" anchor="ctr" wrap="square"/>
+          <a:lstStyle/>
+          <a:p>
+            <a:pPr algn="ctr"/>
+          </a:p>
+        </p:txBody>
+      </p:sp>
+      <p:sp>
+        <p:nvSpPr>
+          <p:cNvPr id="43" name="TextBox 42"/>
+          <p:cNvSpPr txBox="1"/>
+          <p:nvPr/>
+        </p:nvSpPr>
+        <p:spPr>
+          <a:xfrm>
+            <a:off x="9400032" y="3584448"/>
+            <a:ext cx="2240280" cy="292608"/>
+          </a:xfrm>
+          <a:prstGeom prst="rect">
+            <a:avLst/>
+          </a:prstGeom>
+          <a:noFill/>
+        </p:spPr>
+        <p:txBody>
+          <a:bodyPr wrap="square" anchor="t" lIns="38100" rIns="38100" tIns="12700" bIns="12700">
+            <a:spAutoFit/>
+          </a:bodyPr>
+          <a:lstStyle/>
+          <a:p>
+            <a:pPr algn="l">
+              <a:spcAft>
+                <a:spcPts val="600"/>
+              </a:spcAft>
+            </a:pPr>
+            <a:r>
+              <a:rPr sz="1400" b="1">
+                <a:solidFill>
+                  <a:srgbClr val="013A57"/>
+                </a:solidFill>
+                <a:latin typeface="Calibri"/>
+              </a:rPr>
+              <a:t>function calling</a:t>
+            </a:r>
+          </a:p>
+        </p:txBody>
+      </p:sp>
+      <p:sp>
+        <p:nvSpPr>
+          <p:cNvPr id="44" name="TextBox 43"/>
+          <p:cNvSpPr txBox="1"/>
+          <p:nvPr/>
+        </p:nvSpPr>
+        <p:spPr>
+          <a:xfrm>
+            <a:off x="9400032" y="3904488"/>
+            <a:ext cx="2240280" cy="868680"/>
+          </a:xfrm>
+          <a:prstGeom prst="rect">
+            <a:avLst/>
+          </a:prstGeom>
+          <a:noFill/>
+        </p:spPr>
+        <p:txBody>
+          <a:bodyPr wrap="square" anchor="t" lIns="38100" rIns="38100" tIns="12700" bIns="12700">
+            <a:spAutoFit/>
+          </a:bodyPr>
+          <a:lstStyle/>
+          <a:p>
+            <a:pPr algn="l">
+              <a:spcAft>
+                <a:spcPts val="600"/>
+              </a:spcAft>
+            </a:pPr>
+            <a:r>
+              <a:rPr sz="1150" b="0">
+                <a:solidFill>
+                  <a:srgbClr val="4A5B68"/>
+                </a:solidFill>
+                <a:latin typeface="Calibri"/>
+              </a:rPr>
+              <a:t>El mecanismo por el que PIDE la cifra en vez de inventarla.</a:t>
+            </a:r>
+          </a:p>
+        </p:txBody>
+      </p:sp>
+      <p:sp>
+        <p:nvSpPr>
+          <p:cNvPr id="45" name="Rectangle 44"/>
           <p:cNvSpPr/>
           <p:nvPr/>
         </p:nvSpPr>
@@ -11196,7 +11760,7 @@
       </p:sp>
       <p:sp>
         <p:nvSpPr>
-          <p:cNvPr id="26" name="Rectangle 25"/>
+          <p:cNvPr id="46" name="Rectangle 45"/>
           <p:cNvSpPr/>
           <p:nvPr/>
         </p:nvSpPr>
@@ -11240,7 +11804,7 @@
       </p:sp>
       <p:sp>
         <p:nvSpPr>
-          <p:cNvPr id="27" name="TextBox 26"/>
+          <p:cNvPr id="47" name="TextBox 46"/>
           <p:cNvSpPr txBox="1"/>
           <p:nvPr/>
         </p:nvSpPr>
@@ -11279,7 +11843,7 @@
       </p:sp>
       <p:sp>
         <p:nvSpPr>
-          <p:cNvPr id="28" name="Rectangle 27"/>
+          <p:cNvPr id="48" name="Rectangle 47"/>
           <p:cNvSpPr/>
           <p:nvPr/>
         </p:nvSpPr>
@@ -11323,7 +11887,7 @@
       </p:sp>
       <p:sp>
         <p:nvSpPr>
-          <p:cNvPr id="29" name="Rectangle 28"/>
+          <p:cNvPr id="49" name="Rectangle 48"/>
           <p:cNvSpPr/>
           <p:nvPr/>
         </p:nvSpPr>
@@ -11367,7 +11931,7 @@
       </p:sp>
       <p:sp>
         <p:nvSpPr>
-          <p:cNvPr id="30" name="TextBox 29"/>
+          <p:cNvPr id="50" name="TextBox 49"/>
           <p:cNvSpPr txBox="1"/>
           <p:nvPr/>
         </p:nvSpPr>

</xml_diff>

<commit_message>
Presentacion: corregir estructura (bug 12x4=27), pdfplumber y "cifras"->"registros"
Sobre la version de 7 diapositivas de Carlos:
- Estructura: quitado el "N parametros x N jurisdicciones = N celdas" de biometano e
  hidrogeno (era falso: 12x4=48 != 27, 18x6=108 != 40, porque las jurisdicciones son
  desiguales). Ahora "12 parametros - 27 celdas" y "18 parametros - 40 celdas".
- Capa 3 = pdfplumber (extrae el TEXTO para el buscador); la Capa 1 (documentos) ya no
  lleva ese tag, para no sugerir que las cifras se auto-extraen.
- "cifras/valores trazables" -> "registros trazables" donde el conteo (277) incluye
  huecos "no fijado" (222 con valor + 55 sin).

Co-Authored-By: Claude Opus 4.8 (1M context) <noreply@anthropic.com>
</commit_message>
<xml_diff>
--- a/docs/Presentacion_Comparador_Gas.pptx
+++ b/docs/Presentacion_Comparador_Gas.pptx
@@ -578,7 +578,7 @@
           <a:lstStyle/>
           <a:p>
             <a:r>
-              <a:t>[~50 s] Recordad las cuatro cifras y saltad rápido al problema: la información regulatoria está dispersa y, sobre todo, NO ES DIRECTAMENTE COMPARABLE, porque cada país usa unidades y condiciones distintas. Y la promesa: cero cifras inventadas. De los 277 valores trazables, 209 están verificados verbatim, 20 por fuente pública secundaria (cuando la norma primaria es de pago) y 48 declarados 'no verificable' porque la norma no los fija. Cerrad enlazando: 'esto se sostiene sobre dos piezas, la arquitectura y la ontología'.</a:t>
+              <a:t>[~50 s] Recordad las cuatro cifras y saltad rápido al problema: la información regulatoria está dispersa y, sobre todo, NO ES DIRECTAMENTE COMPARABLE, porque cada país usa unidades y condiciones distintas. Y la promesa: cero cifras inventadas. De los 277 registros trazables, 209 están verificados verbatim, 20 por fuente pública secundaria (cuando la norma primaria es de pago) y 48 declarados 'no verificable' porque la norma no los fija. Cerrad enlazando: 'esto se sostiene sobre dos piezas, la arquitectura y la ontología'.</a:t>
             </a:r>
           </a:p>
         </p:txBody>
@@ -5009,7 +5009,7 @@
                 </a:solidFill>
                 <a:latin typeface="Calibri"/>
               </a:rPr>
-              <a:t>valores trazables</a:t>
+              <a:t>registros trazables</a:t>
             </a:r>
           </a:p>
         </p:txBody>
@@ -7136,7 +7136,7 @@
                 </a:solidFill>
                 <a:latin typeface="Calibri"/>
               </a:rPr>
-              <a:t>Las 277 cifras, cada una con su unidad, sus condiciones y su cita oficial.</a:t>
+              <a:t>Los 277 registros, cada uno con su valor, unidad, condiciones y su cita oficial.</a:t>
             </a:r>
           </a:p>
         </p:txBody>
@@ -8077,7 +8077,7 @@
                 </a:solidFill>
                 <a:latin typeface="Calibri"/>
               </a:rPr>
-              <a:t>pdfplumber</a:t>
+              <a:t>PDF oficial</a:t>
             </a:r>
           </a:p>
         </p:txBody>
@@ -8286,7 +8286,7 @@
                 </a:solidFill>
                 <a:latin typeface="Calibri"/>
               </a:rPr>
-              <a:t>• Las 277 cifras extraídas de esos PDF, con su contexto y su cita.</a:t>
+              <a:t>• Los 277 registros extraídos de esos PDF, con su contexto y su cita.</a:t>
             </a:r>
           </a:p>
           <a:p>
@@ -8612,7 +8612,7 @@
                 </a:solidFill>
                 <a:latin typeface="Calibri"/>
               </a:rPr>
-              <a:t>• El TEXTO de los PDF troceado en fragmentos con solape.</a:t>
+              <a:t>• pdfplumber trocea el TEXTO de los PDF en fragmentos con solape.</a:t>
             </a:r>
           </a:p>
           <a:p>
@@ -10627,7 +10627,7 @@
                 </a:solidFill>
                 <a:latin typeface="Calibri"/>
               </a:rPr>
-              <a:t>BIOMETANO — 12 parámetros × 4 jurisdicciones = 27 celdas.</a:t>
+              <a:t>BIOMETANO — 12 parámetros · 27 celdas (4 jurisdicciones: ES · PT · FR · UE).</a:t>
             </a:r>
           </a:p>
         </p:txBody>
@@ -10841,7 +10841,7 @@
                 </a:solidFill>
                 <a:latin typeface="Calibri"/>
               </a:rPr>
-              <a:t>HIDRÓGENO — 18 parámetros × 6 jurisdicciones = 40 celdas.</a:t>
+              <a:t>HIDRÓGENO — 18 parámetros · 40 celdas (dominio de red + producto).</a:t>
             </a:r>
           </a:p>
         </p:txBody>

</xml_diff>